<commit_message>
Sync project content after the final fixes
slide-rebuild-log a25ad20 (kept-line wording), architecture-three-ways
de93d76 (cFE Apps drawn with no status color) and chart-rebuilds ba1daa7
(sentence-case title).

Co-Authored-By: Claude Opus 5.5 <noreply@anthropic.com>
Claude-Session: https://claude.ai/code/session_01QhAcegZCA84C1dHz9XeXfw
</commit_message>
<xml_diff>
--- a/public/projects/architecture-three-ways/dist/architecture-three-ways.pptx
+++ b/public/projects/architecture-three-ways/dist/architecture-three-ways.pptx
@@ -3001,11 +3001,11 @@
             </a:avLst>
           </a:prstGeom>
           <a:solidFill>
-            <a:srgbClr val="DCE6F0"/>
-          </a:solidFill>
-          <a:ln w="12700">
+            <a:srgbClr val="FFFFFF"/>
+          </a:solidFill>
+          <a:ln w="9525">
             <a:solidFill>
-              <a:srgbClr val="2F5D8A"/>
+              <a:srgbClr val="7C8591"/>
             </a:solidFill>
             <a:prstDash val="solid"/>
           </a:ln>
@@ -3028,11 +3028,11 @@
             </a:avLst>
           </a:prstGeom>
           <a:solidFill>
-            <a:srgbClr val="DCE6F0"/>
-          </a:solidFill>
-          <a:ln w="12700">
+            <a:srgbClr val="FFFFFF"/>
+          </a:solidFill>
+          <a:ln w="9525">
             <a:solidFill>
-              <a:srgbClr val="2F5D8A"/>
+              <a:srgbClr val="7C8591"/>
             </a:solidFill>
             <a:prstDash val="solid"/>
           </a:ln>
@@ -3055,11 +3055,11 @@
             </a:avLst>
           </a:prstGeom>
           <a:solidFill>
-            <a:srgbClr val="DCE6F0"/>
-          </a:solidFill>
-          <a:ln w="12700">
+            <a:srgbClr val="FFFFFF"/>
+          </a:solidFill>
+          <a:ln w="9525">
             <a:solidFill>
-              <a:srgbClr val="2F5D8A"/>
+              <a:srgbClr val="7C8591"/>
             </a:solidFill>
             <a:prstDash val="solid"/>
           </a:ln>

</xml_diff>